<commit_message>
Add weekly timeline checkpoint to Monday slide
</commit_message>
<xml_diff>
--- a/outputs/monday_update_ethylene_cracker.pptx
+++ b/outputs/monday_update_ethylene_cracker.pptx
@@ -2,13 +2,13 @@
 <file path=ppt/presentation.xml><?xml version="1.0" encoding="utf-8"?>
 <p:presentation xmlns:p="http://schemas.openxmlformats.org/presentationml/2006/main">
   <p:sldMasterIdLst>
-    <p:sldMasterId xmlns:r="http://schemas.openxmlformats.org/officeDocument/2006/relationships" id="2147483648" r:id="R1306a32ac26043f2"/>
+    <p:sldMasterId xmlns:r="http://schemas.openxmlformats.org/officeDocument/2006/relationships" id="2147483648" r:id="Rd4a83e4c0781448a"/>
   </p:sldMasterIdLst>
   <p:notesMasterIdLst>
-    <p:notesMasterId xmlns:r="http://schemas.openxmlformats.org/officeDocument/2006/relationships" r:id="R29df3c7886b74818"/>
+    <p:notesMasterId xmlns:r="http://schemas.openxmlformats.org/officeDocument/2006/relationships" r:id="Ra83d3b5c05044536"/>
   </p:notesMasterIdLst>
   <p:sldIdLst>
-    <p:sldId xmlns:r="http://schemas.openxmlformats.org/officeDocument/2006/relationships" id="256" r:id="R4da17a395a1d452c"/>
+    <p:sldId xmlns:r="http://schemas.openxmlformats.org/officeDocument/2006/relationships" id="256" r:id="R091b0adbf58b4ffe"/>
   </p:sldIdLst>
   <p:sldSz cx="12192000" cy="6858000"/>
   <p:notesSz cx="6858000" cy="9144000"/>
@@ -545,7 +545,7 @@
   </p:cSld>
   <p:clrMap bg1="lt1" tx1="dk1" bg2="lt2" tx2="dk2" accent1="accent1" accent2="accent2" accent3="accent3" accent4="accent4" accent5="accent5" accent6="accent6" hlink="hlink" folHlink="folHlink"/>
   <p:sldLayoutIdLst>
-    <p:sldLayoutId xmlns:r="http://schemas.openxmlformats.org/officeDocument/2006/relationships" id="2147483649" r:id="R1bced9808d624ae9"/>
+    <p:sldLayoutId xmlns:r="http://schemas.openxmlformats.org/officeDocument/2006/relationships" id="2147483649" r:id="R8b33c402eead438d"/>
   </p:sldLayoutIdLst>
   <p:txStyles>
     <p:titleStyle>
@@ -1390,6 +1390,7 @@
           <a:lstStyle xmlns:a="http://schemas.openxmlformats.org/drawingml/2006/main"/>
           <a:p xmlns:a="http://schemas.openxmlformats.org/drawingml/2006/main">
             <a:pPr>
+              <a:buNone/>
               <a:defRPr sz="975" b="1">
                 <a:solidFill>
                   <a:srgbClr val="3D8DFF"/>
@@ -1448,6 +1449,7 @@
           <a:lstStyle xmlns:a="http://schemas.openxmlformats.org/drawingml/2006/main"/>
           <a:p xmlns:a="http://schemas.openxmlformats.org/drawingml/2006/main">
             <a:pPr>
+              <a:buNone/>
               <a:defRPr sz="2625" b="1">
                 <a:solidFill>
                   <a:srgbClr val="162236"/>
@@ -1506,6 +1508,7 @@
           <a:lstStyle xmlns:a="http://schemas.openxmlformats.org/drawingml/2006/main"/>
           <a:p xmlns:a="http://schemas.openxmlformats.org/drawingml/2006/main">
             <a:pPr>
+              <a:buNone/>
               <a:defRPr sz="1350">
                 <a:solidFill>
                   <a:srgbClr val="526071"/>
@@ -1605,6 +1608,7 @@
           <a:lstStyle xmlns:a="http://schemas.openxmlformats.org/drawingml/2006/main"/>
           <a:p xmlns:a="http://schemas.openxmlformats.org/drawingml/2006/main">
             <a:pPr>
+              <a:buNone/>
               <a:defRPr sz="1500" b="1">
                 <a:solidFill>
                   <a:srgbClr val="162236"/>
@@ -1663,6 +1667,7 @@
           <a:lstStyle xmlns:a="http://schemas.openxmlformats.org/drawingml/2006/main"/>
           <a:p xmlns:a="http://schemas.openxmlformats.org/drawingml/2006/main">
             <a:pPr>
+              <a:buNone/>
               <a:defRPr sz="975">
                 <a:solidFill>
                   <a:srgbClr val="526071"/>
@@ -1688,7 +1693,7 @@
       </p:sp>
       <p:graphicFrame>
         <p:nvGraphicFramePr>
-          <p:cNvPr id="34" name="Chart"/>
+          <p:cNvPr id="36" name="Chart"/>
           <p:cNvGraphicFramePr/>
           <p:nvPr/>
         </p:nvGraphicFramePr>
@@ -1698,7 +1703,7 @@
         </p:xfrm>
         <a:graphic xmlns:a="http://schemas.openxmlformats.org/drawingml/2006/main">
           <a:graphicData uri="http://schemas.openxmlformats.org/drawingml/2006/chart">
-            <c:chart xmlns:r="http://schemas.openxmlformats.org/officeDocument/2006/relationships" xmlns:c="http://schemas.openxmlformats.org/drawingml/2006/chart" r:id="R37d9d4360df14480"/>
+            <c:chart xmlns:r="http://schemas.openxmlformats.org/officeDocument/2006/relationships" xmlns:c="http://schemas.openxmlformats.org/drawingml/2006/chart" r:id="R3a868412584949da"/>
           </a:graphicData>
         </a:graphic>
       </p:graphicFrame>
@@ -1778,6 +1783,7 @@
           <a:lstStyle xmlns:a="http://schemas.openxmlformats.org/drawingml/2006/main"/>
           <a:p xmlns:a="http://schemas.openxmlformats.org/drawingml/2006/main">
             <a:pPr>
+              <a:buNone/>
               <a:defRPr sz="1500" b="1">
                 <a:solidFill>
                   <a:srgbClr val="162236"/>
@@ -1836,6 +1842,7 @@
           <a:lstStyle xmlns:a="http://schemas.openxmlformats.org/drawingml/2006/main"/>
           <a:p xmlns:a="http://schemas.openxmlformats.org/drawingml/2006/main">
             <a:pPr>
+              <a:buNone/>
               <a:defRPr sz="825" b="1">
                 <a:solidFill>
                   <a:srgbClr val="3D8DFF"/>
@@ -2041,6 +2048,7 @@
           <a:lstStyle xmlns:a="http://schemas.openxmlformats.org/drawingml/2006/main"/>
           <a:p xmlns:a="http://schemas.openxmlformats.org/drawingml/2006/main">
             <a:pPr>
+              <a:buNone/>
               <a:defRPr sz="825" b="1">
                 <a:solidFill>
                   <a:srgbClr val="0A7780"/>
@@ -2248,6 +2256,7 @@
           <a:lstStyle xmlns:a="http://schemas.openxmlformats.org/drawingml/2006/main"/>
           <a:p xmlns:a="http://schemas.openxmlformats.org/drawingml/2006/main">
             <a:pPr algn="ctr">
+              <a:buNone/>
               <a:defRPr sz="2550" b="1">
                 <a:solidFill>
                   <a:srgbClr val="162236"/>
@@ -2306,6 +2315,7 @@
           <a:lstStyle xmlns:a="http://schemas.openxmlformats.org/drawingml/2006/main"/>
           <a:p xmlns:a="http://schemas.openxmlformats.org/drawingml/2006/main">
             <a:pPr algn="ctr">
+              <a:buNone/>
               <a:defRPr sz="975" b="1">
                 <a:solidFill>
                   <a:srgbClr val="526071"/>
@@ -2397,6 +2407,7 @@
           <a:lstStyle xmlns:a="http://schemas.openxmlformats.org/drawingml/2006/main"/>
           <a:p xmlns:a="http://schemas.openxmlformats.org/drawingml/2006/main">
             <a:pPr algn="ctr">
+              <a:buNone/>
               <a:defRPr sz="2550" b="1">
                 <a:solidFill>
                   <a:srgbClr val="0A7780"/>
@@ -2455,6 +2466,7 @@
           <a:lstStyle xmlns:a="http://schemas.openxmlformats.org/drawingml/2006/main"/>
           <a:p xmlns:a="http://schemas.openxmlformats.org/drawingml/2006/main">
             <a:pPr algn="ctr">
+              <a:buNone/>
               <a:defRPr sz="975" b="1">
                 <a:solidFill>
                   <a:srgbClr val="526071"/>
@@ -2546,6 +2558,7 @@
           <a:lstStyle xmlns:a="http://schemas.openxmlformats.org/drawingml/2006/main"/>
           <a:p xmlns:a="http://schemas.openxmlformats.org/drawingml/2006/main">
             <a:pPr algn="ctr">
+              <a:buNone/>
               <a:defRPr sz="1125" b="1">
                 <a:solidFill>
                   <a:srgbClr val="FFFFFF"/>
@@ -2564,7 +2577,7 @@
                 <a:ea typeface="Aptos"/>
                 <a:cs typeface="Aptos"/>
               </a:rPr>
-              <a:t>FULL COMPUTED DATASET    16,628 pairs   ·   1,940 MOFs   ·   113 molecules   ·   300 K   ·   linear K</a:t>
+              <a:t>THIS WEEK COMPLETE    ✓ Repo + data    ✓ Inventory + units    ✓ 8-gas panel    ✓ 471 × 8 coverage matrix</a:t>
             </a:r>
           </a:p>
         </p:txBody>
@@ -2637,6 +2650,7 @@
           <a:lstStyle xmlns:a="http://schemas.openxmlformats.org/drawingml/2006/main"/>
           <a:p xmlns:a="http://schemas.openxmlformats.org/drawingml/2006/main">
             <a:pPr algn="ctr">
+              <a:buNone/>
               <a:defRPr sz="975" b="1">
                 <a:solidFill>
                   <a:srgbClr val="162236"/>
@@ -2695,6 +2709,7 @@
           <a:lstStyle xmlns:a="http://schemas.openxmlformats.org/drawingml/2006/main"/>
           <a:p xmlns:a="http://schemas.openxmlformats.org/drawingml/2006/main">
             <a:pPr>
+              <a:buNone/>
               <a:defRPr sz="1350" b="1">
                 <a:solidFill>
                   <a:srgbClr val="162236"/>

</xml_diff>

<commit_message>
Add next-step roadmap graphic to Monday slide
</commit_message>
<xml_diff>
--- a/outputs/monday_update_ethylene_cracker.pptx
+++ b/outputs/monday_update_ethylene_cracker.pptx
@@ -2,13 +2,13 @@
 <file path=ppt/presentation.xml><?xml version="1.0" encoding="utf-8"?>
 <p:presentation xmlns:p="http://schemas.openxmlformats.org/presentationml/2006/main">
   <p:sldMasterIdLst>
-    <p:sldMasterId xmlns:r="http://schemas.openxmlformats.org/officeDocument/2006/relationships" id="2147483648" r:id="Rd4a83e4c0781448a"/>
+    <p:sldMasterId xmlns:r="http://schemas.openxmlformats.org/officeDocument/2006/relationships" id="2147483648" r:id="Rddc1d0131d2e4560"/>
   </p:sldMasterIdLst>
   <p:notesMasterIdLst>
-    <p:notesMasterId xmlns:r="http://schemas.openxmlformats.org/officeDocument/2006/relationships" r:id="Ra83d3b5c05044536"/>
+    <p:notesMasterId xmlns:r="http://schemas.openxmlformats.org/officeDocument/2006/relationships" r:id="Recfa702ffbf74374"/>
   </p:notesMasterIdLst>
   <p:sldIdLst>
-    <p:sldId xmlns:r="http://schemas.openxmlformats.org/officeDocument/2006/relationships" id="256" r:id="R091b0adbf58b4ffe"/>
+    <p:sldId xmlns:r="http://schemas.openxmlformats.org/officeDocument/2006/relationships" id="256" r:id="Rcf20434451d54ce6"/>
   </p:sldIdLst>
   <p:sldSz cx="12192000" cy="6858000"/>
   <p:notesSz cx="6858000" cy="9144000"/>
@@ -545,7 +545,7 @@
   </p:cSld>
   <p:clrMap bg1="lt1" tx1="dk1" bg2="lt2" tx2="dk2" accent1="accent1" accent2="accent2" accent3="accent3" accent4="accent4" accent5="accent5" accent6="accent6" hlink="hlink" folHlink="folHlink"/>
   <p:sldLayoutIdLst>
-    <p:sldLayoutId xmlns:r="http://schemas.openxmlformats.org/officeDocument/2006/relationships" id="2147483649" r:id="R8b33c402eead438d"/>
+    <p:sldLayoutId xmlns:r="http://schemas.openxmlformats.org/officeDocument/2006/relationships" id="2147483649" r:id="R693f266901ce4656"/>
   </p:sldLayoutIdLst>
   <p:txStyles>
     <p:titleStyle>
@@ -1703,7 +1703,7 @@
         </p:xfrm>
         <a:graphic xmlns:a="http://schemas.openxmlformats.org/drawingml/2006/main">
           <a:graphicData uri="http://schemas.openxmlformats.org/drawingml/2006/chart">
-            <c:chart xmlns:r="http://schemas.openxmlformats.org/officeDocument/2006/relationships" xmlns:c="http://schemas.openxmlformats.org/drawingml/2006/chart" r:id="R3a868412584949da"/>
+            <c:chart xmlns:r="http://schemas.openxmlformats.org/officeDocument/2006/relationships" xmlns:c="http://schemas.openxmlformats.org/drawingml/2006/chart" r:id="Ra22437fc2af7422e"/>
           </a:graphicData>
         </a:graphic>
       </p:graphicFrame>
@@ -2728,7 +2728,7 @@
                 <a:ea typeface="Aptos"/>
                 <a:cs typeface="Aptos"/>
               </a:rPr>
-              <a:t>Select 12 MOFs  →  test gas identification, composition drift &amp; product/feed ratios  →  reduce if performance holds</a:t>
+              <a:t>① Analyze 471 × 8 response patterns  →  ② Select 12 MOFs  →  ③ Test gas ID • mixtures • drift • ratios  →  ④ Prune</a:t>
             </a:r>
           </a:p>
         </p:txBody>

</xml_diff>